<commit_message>
atualização do material do aluno
</commit_message>
<xml_diff>
--- a/plano-de-aulas/aula-04-slides.pptx
+++ b/plano-de-aulas/aula-04-slides.pptx
@@ -3491,7 +3491,7 @@
           <a:lstStyle/>
           <a:p>
             <a:r>
-              <a:t>Comunicação assíncrona</a:t>
+              <a:t>Cache com Redis</a:t>
             </a:r>
           </a:p>
         </p:txBody>
@@ -3512,7 +3512,7 @@
           <a:lstStyle/>
           <a:p>
             <a:r>
-              <a:t>BE-JV-010 · Aula 4 · 29/06 · Producer/consumer</a:t>
+              <a:t>BE-JV-010 · Aula 3 · 26/06 · Cache compartilhado</a:t>
             </a:r>
           </a:p>
         </p:txBody>
@@ -3572,17 +3572,17 @@
           <a:lstStyle/>
           <a:p>
             <a:r>
-              <a:t>A gravação é lenta e às vezes o banco está fora.</a:t>
+              <a:t>A consulta de comprovante é muito mais lida que escrita</a:t>
             </a:r>
           </a:p>
           <a:p>
             <a:r>
-              <a:t>O cliente não pode esperar nem perder o comprovante.</a:t>
+              <a:t>e está martelando o banco.</a:t>
             </a:r>
           </a:p>
           <a:p>
             <a:r>
-              <a:t>Como aceitar agora e processar depois?</a:t>
+              <a:t>Como aliviar sem servir dado inconsistente?</a:t>
             </a:r>
           </a:p>
         </p:txBody>
@@ -3659,22 +3659,22 @@
           <a:lstStyle/>
           <a:p>
             <a:r>
-              <a:t>Mensagem × evento</a:t>
+              <a:t>Cache local × distribuído (por que Redis e não um HashMap)</a:t>
             </a:r>
           </a:p>
           <a:p>
             <a:r>
-              <a:t>at-most/at-least/exactly-once (e por que exactly-once é mito)</a:t>
+              <a:t>cache-aside, write-through, write-behind</a:t>
             </a:r>
           </a:p>
           <a:p>
             <a:r>
-              <a:t>Acoplamento temporal</a:t>
+              <a:t>TTL e invalidação</a:t>
             </a:r>
           </a:p>
           <a:p>
             <a:r>
-              <a:t>Idempotência do consumidor</a:t>
+              <a:t>Stampede / thundering herd</a:t>
             </a:r>
           </a:p>
         </p:txBody>
@@ -3751,12 +3751,12 @@
           <a:lstStyle/>
           <a:p>
             <a:r>
-              <a:t>Quem usou IBM MQ / JMS / MQSeries já fez producer/consumer</a:t>
+              <a:t>Cache em tabela de banco e sessão pegajosa no app server</a:t>
             </a:r>
           </a:p>
           <a:p>
             <a:r>
-              <a:t>Muda o ferramental, não o conceito</a:t>
+              <a:t>Redis tira o estado do nó e resolve replicação de sessão</a:t>
             </a:r>
           </a:p>
         </p:txBody>
@@ -3833,17 +3833,17 @@
           <a:lstStyle/>
           <a:p>
             <a:r>
-              <a:t>Desacoplar inferência cara do caminho síncrono</a:t>
+              <a:t>Semantic caching: cachear resposta de LLM por similaridade de embedding</a:t>
             </a:r>
           </a:p>
           <a:p>
             <a:r>
-              <a:t>Filas de tarefas de agentes (workers)</a:t>
+              <a:t>Redis como vector store para RAG</a:t>
             </a:r>
           </a:p>
           <a:p>
             <a:r>
-              <a:t>Human-in-the-loop assíncrono</a:t>
+              <a:t>Cache deixa de ser otimização e vira requisito econômico</a:t>
             </a:r>
           </a:p>
         </p:txBody>
@@ -3920,12 +3920,12 @@
           <a:lstStyle/>
           <a:p>
             <a:r>
-              <a:t>Base: consumidor idempotente (reprocesso não duplica)</a:t>
+              <a:t>Base: TTL + medir hit/miss</a:t>
             </a:r>
           </a:p>
           <a:p>
             <a:r>
-              <a:t>Stretch: simular consumidor lento/caído; discutir backpressure</a:t>
+              <a:t>Stretch: invalidação ao atualizar + mitigar stampede (lock/jitter)</a:t>
             </a:r>
           </a:p>
         </p:txBody>
@@ -3981,7 +3981,7 @@
           <a:lstStyle/>
           <a:p>
             <a:r>
-              <a:t>Assíncrono não é 'mais rápido' — é 'não falhar junto'.</a:t>
+              <a:t>Cache não é guardar tudo — é decidir o que pode estar um pouco velho.</a:t>
             </a:r>
           </a:p>
         </p:txBody>

</xml_diff>